<commit_message>
Legend audit fixes: per-sheet legends now match drawn content exactly
Stop-bar legend row removed from sheets with no stop bar (Location 2);
indicative-duct row added to the PDF legend; indicative-duct and feed
manhole/handhole rows added to the PPTX legend. Works-action rows were
already dynamic per sheet.

Co-Authored-By: Claude Fable 5 <noreply@anthropic.com>
Claude-Session: https://claude.ai/code/session_01N2KftBqxVNP8RaeHWyv1DV
</commit_message>
<xml_diff>
--- a/projects/taxiway-e-agl-milling/drawings/TWY-E-AGL-SHOPDWG-EDITABLE_RevP05.pptx
+++ b/projects/taxiway-e-agl-milling/drawings/TWY-E-AGL-SHOPDWG-EDITABLE_RevP05.pptx
@@ -10640,7 +10640,7 @@
         <p:spPr>
           <a:xfrm>
             <a:off x="10104120" y="7047281"/>
-            <a:ext cx="4709160" cy="3419856"/>
+            <a:ext cx="4709160" cy="3968496"/>
           </a:xfrm>
           <a:prstGeom prst="rect">
             <a:avLst/>
@@ -11179,6 +11179,68 @@
             <a:avLst/>
           </a:prstGeom>
           <a:noFill/>
+          <a:ln w="12700">
+            <a:solidFill>
+              <a:srgbClr val="C9CDD2"/>
+            </a:solidFill>
+            <a:prstDash val="dash"/>
+          </a:ln>
+        </p:spPr>
+      </p:sp>
+      <p:sp>
+        <p:nvSpPr>
+          <p:cNvPr id="338" name="Text 336"/>
+          <p:cNvSpPr/>
+          <p:nvPr/>
+        </p:nvSpPr>
+        <p:spPr>
+          <a:xfrm>
+            <a:off x="10616184" y="9077249"/>
+            <a:ext cx="4050792" cy="237744"/>
+          </a:xfrm>
+          <a:prstGeom prst="rect">
+            <a:avLst/>
+          </a:prstGeom>
+          <a:noFill/>
+          <a:ln/>
+        </p:spPr>
+        <p:txBody>
+          <a:bodyPr wrap="square" lIns="0" tIns="0" rIns="0" bIns="0" rtlCol="0" anchor="ctr"/>
+          <a:lstStyle/>
+          <a:p>
+            <a:pPr indent="0" marL="0">
+              <a:buNone/>
+            </a:pPr>
+            <a:r>
+              <a:rPr lang="en-US" sz="740" dirty="0">
+                <a:solidFill>
+                  <a:srgbClr val="1F2937"/>
+                </a:solidFill>
+                <a:latin typeface="Arial" pitchFamily="34" charset="0"/>
+                <a:ea typeface="Arial" pitchFamily="34" charset="-122"/>
+                <a:cs typeface="Arial" pitchFamily="34" charset="-120"/>
+              </a:rPr>
+              <a:t>INDICATIVE DUCT — LIGHT TO NEAREST MH/HH</a:t>
+            </a:r>
+            <a:endParaRPr lang="en-US" sz="740" dirty="0"/>
+          </a:p>
+        </p:txBody>
+      </p:sp>
+      <p:sp>
+        <p:nvSpPr>
+          <p:cNvPr id="339" name="Shape 337"/>
+          <p:cNvSpPr/>
+          <p:nvPr/>
+        </p:nvSpPr>
+        <p:spPr>
+          <a:xfrm>
+            <a:off x="10268712" y="9461297"/>
+            <a:ext cx="274320" cy="914"/>
+          </a:xfrm>
+          <a:prstGeom prst="line">
+            <a:avLst/>
+          </a:prstGeom>
+          <a:noFill/>
           <a:ln w="19050">
             <a:solidFill>
               <a:srgbClr val="BB00BB"/>
@@ -11189,13 +11251,13 @@
       </p:sp>
       <p:sp>
         <p:nvSpPr>
-          <p:cNvPr id="338" name="Text 336"/>
-          <p:cNvSpPr/>
-          <p:nvPr/>
-        </p:nvSpPr>
-        <p:spPr>
-          <a:xfrm>
-            <a:off x="10616184" y="9077249"/>
+          <p:cNvPr id="340" name="Text 338"/>
+          <p:cNvSpPr/>
+          <p:nvPr/>
+        </p:nvSpPr>
+        <p:spPr>
+          <a:xfrm>
+            <a:off x="10616184" y="9351569"/>
             <a:ext cx="4050792" cy="237744"/>
           </a:xfrm>
           <a:prstGeom prst="rect">
@@ -11228,13 +11290,13 @@
       </p:sp>
       <p:sp>
         <p:nvSpPr>
-          <p:cNvPr id="339" name="Shape 337"/>
-          <p:cNvSpPr/>
-          <p:nvPr/>
-        </p:nvSpPr>
-        <p:spPr>
-          <a:xfrm>
-            <a:off x="10268712" y="9461297"/>
+          <p:cNvPr id="341" name="Shape 339"/>
+          <p:cNvSpPr/>
+          <p:nvPr/>
+        </p:nvSpPr>
+        <p:spPr>
+          <a:xfrm>
+            <a:off x="10268712" y="9735617"/>
             <a:ext cx="274320" cy="914"/>
           </a:xfrm>
           <a:prstGeom prst="line">
@@ -11251,13 +11313,13 @@
       </p:sp>
       <p:sp>
         <p:nvSpPr>
-          <p:cNvPr id="340" name="Text 338"/>
-          <p:cNvSpPr/>
-          <p:nvPr/>
-        </p:nvSpPr>
-        <p:spPr>
-          <a:xfrm>
-            <a:off x="10616184" y="9351569"/>
+          <p:cNvPr id="342" name="Text 340"/>
+          <p:cNvSpPr/>
+          <p:nvPr/>
+        </p:nvSpPr>
+        <p:spPr>
+          <a:xfrm>
+            <a:off x="10616184" y="9625889"/>
             <a:ext cx="4050792" cy="237744"/>
           </a:xfrm>
           <a:prstGeom prst="rect">
@@ -11290,13 +11352,13 @@
       </p:sp>
       <p:sp>
         <p:nvSpPr>
-          <p:cNvPr id="341" name="Shape 339"/>
-          <p:cNvSpPr/>
-          <p:nvPr/>
-        </p:nvSpPr>
-        <p:spPr>
-          <a:xfrm>
-            <a:off x="10268712" y="9735617"/>
+          <p:cNvPr id="343" name="Shape 341"/>
+          <p:cNvSpPr/>
+          <p:nvPr/>
+        </p:nvSpPr>
+        <p:spPr>
+          <a:xfrm>
+            <a:off x="10268712" y="10009937"/>
             <a:ext cx="274320" cy="914"/>
           </a:xfrm>
           <a:prstGeom prst="line">
@@ -11313,13 +11375,13 @@
       </p:sp>
       <p:sp>
         <p:nvSpPr>
-          <p:cNvPr id="342" name="Text 340"/>
-          <p:cNvSpPr/>
-          <p:nvPr/>
-        </p:nvSpPr>
-        <p:spPr>
-          <a:xfrm>
-            <a:off x="10616184" y="9625889"/>
+          <p:cNvPr id="344" name="Text 342"/>
+          <p:cNvSpPr/>
+          <p:nvPr/>
+        </p:nvSpPr>
+        <p:spPr>
+          <a:xfrm>
+            <a:off x="10616184" y="9900209"/>
             <a:ext cx="4050792" cy="237744"/>
           </a:xfrm>
           <a:prstGeom prst="rect">
@@ -11352,13 +11414,13 @@
       </p:sp>
       <p:sp>
         <p:nvSpPr>
-          <p:cNvPr id="343" name="Shape 341"/>
-          <p:cNvSpPr/>
-          <p:nvPr/>
-        </p:nvSpPr>
-        <p:spPr>
-          <a:xfrm>
-            <a:off x="10268712" y="10009937"/>
+          <p:cNvPr id="345" name="Shape 343"/>
+          <p:cNvSpPr/>
+          <p:nvPr/>
+        </p:nvSpPr>
+        <p:spPr>
+          <a:xfrm>
+            <a:off x="10268712" y="10284257"/>
             <a:ext cx="274320" cy="914"/>
           </a:xfrm>
           <a:prstGeom prst="line">
@@ -11375,13 +11437,13 @@
       </p:sp>
       <p:sp>
         <p:nvSpPr>
-          <p:cNvPr id="344" name="Text 342"/>
-          <p:cNvSpPr/>
-          <p:nvPr/>
-        </p:nvSpPr>
-        <p:spPr>
-          <a:xfrm>
-            <a:off x="10616184" y="9900209"/>
+          <p:cNvPr id="346" name="Text 344"/>
+          <p:cNvSpPr/>
+          <p:nvPr/>
+        </p:nvSpPr>
+        <p:spPr>
+          <a:xfrm>
+            <a:off x="10616184" y="10174529"/>
             <a:ext cx="4050792" cy="237744"/>
           </a:xfrm>
           <a:prstGeom prst="rect">
@@ -11414,13 +11476,13 @@
       </p:sp>
       <p:sp>
         <p:nvSpPr>
-          <p:cNvPr id="345" name="Shape 343"/>
-          <p:cNvSpPr/>
-          <p:nvPr/>
-        </p:nvSpPr>
-        <p:spPr>
-          <a:xfrm>
-            <a:off x="10268712" y="10284257"/>
+          <p:cNvPr id="347" name="Shape 345"/>
+          <p:cNvSpPr/>
+          <p:nvPr/>
+        </p:nvSpPr>
+        <p:spPr>
+          <a:xfrm>
+            <a:off x="10268712" y="10558577"/>
             <a:ext cx="274320" cy="914"/>
           </a:xfrm>
           <a:prstGeom prst="line">
@@ -11437,13 +11499,13 @@
       </p:sp>
       <p:sp>
         <p:nvSpPr>
-          <p:cNvPr id="346" name="Text 344"/>
-          <p:cNvSpPr/>
-          <p:nvPr/>
-        </p:nvSpPr>
-        <p:spPr>
-          <a:xfrm>
-            <a:off x="10616184" y="10174529"/>
+          <p:cNvPr id="348" name="Text 346"/>
+          <p:cNvSpPr/>
+          <p:nvPr/>
+        </p:nvSpPr>
+        <p:spPr>
+          <a:xfrm>
+            <a:off x="10616184" y="10448849"/>
             <a:ext cx="4050792" cy="237744"/>
           </a:xfrm>
           <a:prstGeom prst="rect">
@@ -11469,6 +11531,67 @@
                 <a:cs typeface="Arial" pitchFamily="34" charset="-120"/>
               </a:rPr>
               <a:t>TWY EDGE / PAVEMENT BOUNDARY (INDICATIVE 23 m — CONFIRM ON SITE)</a:t>
+            </a:r>
+            <a:endParaRPr lang="en-US" sz="740" dirty="0"/>
+          </a:p>
+        </p:txBody>
+      </p:sp>
+      <p:sp>
+        <p:nvSpPr>
+          <p:cNvPr id="349" name="Shape 347"/>
+          <p:cNvSpPr/>
+          <p:nvPr/>
+        </p:nvSpPr>
+        <p:spPr>
+          <a:xfrm>
+            <a:off x="10287000" y="10750601"/>
+            <a:ext cx="219456" cy="146304"/>
+          </a:xfrm>
+          <a:prstGeom prst="rect">
+            <a:avLst/>
+          </a:prstGeom>
+          <a:ln w="19050">
+            <a:solidFill>
+              <a:srgbClr val="BB00BB"/>
+            </a:solidFill>
+            <a:prstDash val="solid"/>
+          </a:ln>
+        </p:spPr>
+      </p:sp>
+      <p:sp>
+        <p:nvSpPr>
+          <p:cNvPr id="350" name="Text 348"/>
+          <p:cNvSpPr/>
+          <p:nvPr/>
+        </p:nvSpPr>
+        <p:spPr>
+          <a:xfrm>
+            <a:off x="10616184" y="10723169"/>
+            <a:ext cx="4050792" cy="237744"/>
+          </a:xfrm>
+          <a:prstGeom prst="rect">
+            <a:avLst/>
+          </a:prstGeom>
+          <a:noFill/>
+          <a:ln/>
+        </p:spPr>
+        <p:txBody>
+          <a:bodyPr wrap="square" lIns="0" tIns="0" rIns="0" bIns="0" rtlCol="0" anchor="ctr"/>
+          <a:lstStyle/>
+          <a:p>
+            <a:pPr indent="0" marL="0">
+              <a:buNone/>
+            </a:pPr>
+            <a:r>
+              <a:rPr lang="en-US" sz="740" dirty="0">
+                <a:solidFill>
+                  <a:srgbClr val="1F2937"/>
+                </a:solidFill>
+                <a:latin typeface="Arial" pitchFamily="34" charset="0"/>
+                <a:ea typeface="Arial" pitchFamily="34" charset="-122"/>
+                <a:cs typeface="Arial" pitchFamily="34" charset="-120"/>
+              </a:rPr>
+              <a:t>AGL FEED MANHOLE / HANDHOLE</a:t>
             </a:r>
             <a:endParaRPr lang="en-US" sz="740" dirty="0"/>
           </a:p>
@@ -14868,7 +14991,7 @@
         <p:spPr>
           <a:xfrm>
             <a:off x="10104120" y="6121908"/>
-            <a:ext cx="4709160" cy="2596896"/>
+            <a:ext cx="4709160" cy="2871216"/>
           </a:xfrm>
           <a:prstGeom prst="rect">
             <a:avLst/>
@@ -15174,6 +15297,68 @@
             <a:avLst/>
           </a:prstGeom>
           <a:noFill/>
+          <a:ln w="12700">
+            <a:solidFill>
+              <a:srgbClr val="C9CDD2"/>
+            </a:solidFill>
+            <a:prstDash val="dash"/>
+          </a:ln>
+        </p:spPr>
+      </p:sp>
+      <p:sp>
+        <p:nvSpPr>
+          <p:cNvPr id="125" name="Text 123"/>
+          <p:cNvSpPr/>
+          <p:nvPr/>
+        </p:nvSpPr>
+        <p:spPr>
+          <a:xfrm>
+            <a:off x="10616184" y="7328916"/>
+            <a:ext cx="4050792" cy="237744"/>
+          </a:xfrm>
+          <a:prstGeom prst="rect">
+            <a:avLst/>
+          </a:prstGeom>
+          <a:noFill/>
+          <a:ln/>
+        </p:spPr>
+        <p:txBody>
+          <a:bodyPr wrap="square" lIns="0" tIns="0" rIns="0" bIns="0" rtlCol="0" anchor="ctr"/>
+          <a:lstStyle/>
+          <a:p>
+            <a:pPr indent="0" marL="0">
+              <a:buNone/>
+            </a:pPr>
+            <a:r>
+              <a:rPr lang="en-US" sz="740" dirty="0">
+                <a:solidFill>
+                  <a:srgbClr val="1F2937"/>
+                </a:solidFill>
+                <a:latin typeface="Arial" pitchFamily="34" charset="0"/>
+                <a:ea typeface="Arial" pitchFamily="34" charset="-122"/>
+                <a:cs typeface="Arial" pitchFamily="34" charset="-120"/>
+              </a:rPr>
+              <a:t>INDICATIVE DUCT — LIGHT TO NEAREST MH/HH</a:t>
+            </a:r>
+            <a:endParaRPr lang="en-US" sz="740" dirty="0"/>
+          </a:p>
+        </p:txBody>
+      </p:sp>
+      <p:sp>
+        <p:nvSpPr>
+          <p:cNvPr id="126" name="Shape 124"/>
+          <p:cNvSpPr/>
+          <p:nvPr/>
+        </p:nvSpPr>
+        <p:spPr>
+          <a:xfrm>
+            <a:off x="10268712" y="7712964"/>
+            <a:ext cx="274320" cy="914"/>
+          </a:xfrm>
+          <a:prstGeom prst="line">
+            <a:avLst/>
+          </a:prstGeom>
+          <a:noFill/>
           <a:ln w="19050">
             <a:solidFill>
               <a:srgbClr val="BB00BB"/>
@@ -15184,13 +15369,13 @@
       </p:sp>
       <p:sp>
         <p:nvSpPr>
-          <p:cNvPr id="125" name="Text 123"/>
-          <p:cNvSpPr/>
-          <p:nvPr/>
-        </p:nvSpPr>
-        <p:spPr>
-          <a:xfrm>
-            <a:off x="10616184" y="7328916"/>
+          <p:cNvPr id="127" name="Text 125"/>
+          <p:cNvSpPr/>
+          <p:nvPr/>
+        </p:nvSpPr>
+        <p:spPr>
+          <a:xfrm>
+            <a:off x="10616184" y="7603236"/>
             <a:ext cx="4050792" cy="237744"/>
           </a:xfrm>
           <a:prstGeom prst="rect">
@@ -15223,13 +15408,13 @@
       </p:sp>
       <p:sp>
         <p:nvSpPr>
-          <p:cNvPr id="126" name="Shape 124"/>
-          <p:cNvSpPr/>
-          <p:nvPr/>
-        </p:nvSpPr>
-        <p:spPr>
-          <a:xfrm>
-            <a:off x="10268712" y="7712964"/>
+          <p:cNvPr id="128" name="Shape 126"/>
+          <p:cNvSpPr/>
+          <p:nvPr/>
+        </p:nvSpPr>
+        <p:spPr>
+          <a:xfrm>
+            <a:off x="10268712" y="7987284"/>
             <a:ext cx="274320" cy="914"/>
           </a:xfrm>
           <a:prstGeom prst="line">
@@ -15246,13 +15431,13 @@
       </p:sp>
       <p:sp>
         <p:nvSpPr>
-          <p:cNvPr id="127" name="Text 125"/>
-          <p:cNvSpPr/>
-          <p:nvPr/>
-        </p:nvSpPr>
-        <p:spPr>
-          <a:xfrm>
-            <a:off x="10616184" y="7603236"/>
+          <p:cNvPr id="129" name="Text 127"/>
+          <p:cNvSpPr/>
+          <p:nvPr/>
+        </p:nvSpPr>
+        <p:spPr>
+          <a:xfrm>
+            <a:off x="10616184" y="7877556"/>
             <a:ext cx="4050792" cy="237744"/>
           </a:xfrm>
           <a:prstGeom prst="rect">
@@ -15285,13 +15470,13 @@
       </p:sp>
       <p:sp>
         <p:nvSpPr>
-          <p:cNvPr id="128" name="Shape 126"/>
-          <p:cNvSpPr/>
-          <p:nvPr/>
-        </p:nvSpPr>
-        <p:spPr>
-          <a:xfrm>
-            <a:off x="10268712" y="7987284"/>
+          <p:cNvPr id="130" name="Shape 128"/>
+          <p:cNvSpPr/>
+          <p:nvPr/>
+        </p:nvSpPr>
+        <p:spPr>
+          <a:xfrm>
+            <a:off x="10268712" y="8261604"/>
             <a:ext cx="274320" cy="914"/>
           </a:xfrm>
           <a:prstGeom prst="line">
@@ -15308,13 +15493,13 @@
       </p:sp>
       <p:sp>
         <p:nvSpPr>
-          <p:cNvPr id="129" name="Text 127"/>
-          <p:cNvSpPr/>
-          <p:nvPr/>
-        </p:nvSpPr>
-        <p:spPr>
-          <a:xfrm>
-            <a:off x="10616184" y="7877556"/>
+          <p:cNvPr id="131" name="Text 129"/>
+          <p:cNvSpPr/>
+          <p:nvPr/>
+        </p:nvSpPr>
+        <p:spPr>
+          <a:xfrm>
+            <a:off x="10616184" y="8151876"/>
             <a:ext cx="4050792" cy="237744"/>
           </a:xfrm>
           <a:prstGeom prst="rect">
@@ -15347,68 +15532,6 @@
       </p:sp>
       <p:sp>
         <p:nvSpPr>
-          <p:cNvPr id="130" name="Shape 128"/>
-          <p:cNvSpPr/>
-          <p:nvPr/>
-        </p:nvSpPr>
-        <p:spPr>
-          <a:xfrm>
-            <a:off x="10268712" y="8261604"/>
-            <a:ext cx="274320" cy="914"/>
-          </a:xfrm>
-          <a:prstGeom prst="line">
-            <a:avLst/>
-          </a:prstGeom>
-          <a:noFill/>
-          <a:ln w="28575">
-            <a:solidFill>
-              <a:srgbClr val="8B0000"/>
-            </a:solidFill>
-            <a:prstDash val="solid"/>
-          </a:ln>
-        </p:spPr>
-      </p:sp>
-      <p:sp>
-        <p:nvSpPr>
-          <p:cNvPr id="131" name="Text 129"/>
-          <p:cNvSpPr/>
-          <p:nvPr/>
-        </p:nvSpPr>
-        <p:spPr>
-          <a:xfrm>
-            <a:off x="10616184" y="8151876"/>
-            <a:ext cx="4050792" cy="237744"/>
-          </a:xfrm>
-          <a:prstGeom prst="rect">
-            <a:avLst/>
-          </a:prstGeom>
-          <a:noFill/>
-          <a:ln/>
-        </p:spPr>
-        <p:txBody>
-          <a:bodyPr wrap="square" lIns="0" tIns="0" rIns="0" bIns="0" rtlCol="0" anchor="ctr"/>
-          <a:lstStyle/>
-          <a:p>
-            <a:pPr indent="0" marL="0">
-              <a:buNone/>
-            </a:pPr>
-            <a:r>
-              <a:rPr lang="en-US" sz="740" dirty="0">
-                <a:solidFill>
-                  <a:srgbClr val="1F2937"/>
-                </a:solidFill>
-                <a:latin typeface="Arial" pitchFamily="34" charset="0"/>
-                <a:ea typeface="Arial" pitchFamily="34" charset="-122"/>
-                <a:cs typeface="Arial" pitchFamily="34" charset="-120"/>
-              </a:rPr>
-              <a:t>STOP BAR (AS-BUILT, THROUGH SBC FITTINGS)</a:t>
-            </a:r>
-            <a:endParaRPr lang="en-US" sz="740" dirty="0"/>
-          </a:p>
-        </p:txBody>
-      </p:sp>
-      <p:sp>
-        <p:nvSpPr>
           <p:cNvPr id="132" name="Shape 130"/>
           <p:cNvSpPr/>
           <p:nvPr/>
@@ -15464,6 +15587,67 @@
                 <a:cs typeface="Arial" pitchFamily="34" charset="-120"/>
               </a:rPr>
               <a:t>TWY EDGE / PAVEMENT BOUNDARY (INDICATIVE 23 m — CONFIRM ON SITE)</a:t>
+            </a:r>
+            <a:endParaRPr lang="en-US" sz="740" dirty="0"/>
+          </a:p>
+        </p:txBody>
+      </p:sp>
+      <p:sp>
+        <p:nvSpPr>
+          <p:cNvPr id="134" name="Shape 132"/>
+          <p:cNvSpPr/>
+          <p:nvPr/>
+        </p:nvSpPr>
+        <p:spPr>
+          <a:xfrm>
+            <a:off x="10287000" y="8727948"/>
+            <a:ext cx="219456" cy="146304"/>
+          </a:xfrm>
+          <a:prstGeom prst="rect">
+            <a:avLst/>
+          </a:prstGeom>
+          <a:ln w="19050">
+            <a:solidFill>
+              <a:srgbClr val="BB00BB"/>
+            </a:solidFill>
+            <a:prstDash val="solid"/>
+          </a:ln>
+        </p:spPr>
+      </p:sp>
+      <p:sp>
+        <p:nvSpPr>
+          <p:cNvPr id="135" name="Text 133"/>
+          <p:cNvSpPr/>
+          <p:nvPr/>
+        </p:nvSpPr>
+        <p:spPr>
+          <a:xfrm>
+            <a:off x="10616184" y="8700516"/>
+            <a:ext cx="4050792" cy="237744"/>
+          </a:xfrm>
+          <a:prstGeom prst="rect">
+            <a:avLst/>
+          </a:prstGeom>
+          <a:noFill/>
+          <a:ln/>
+        </p:spPr>
+        <p:txBody>
+          <a:bodyPr wrap="square" lIns="0" tIns="0" rIns="0" bIns="0" rtlCol="0" anchor="ctr"/>
+          <a:lstStyle/>
+          <a:p>
+            <a:pPr indent="0" marL="0">
+              <a:buNone/>
+            </a:pPr>
+            <a:r>
+              <a:rPr lang="en-US" sz="740" dirty="0">
+                <a:solidFill>
+                  <a:srgbClr val="1F2937"/>
+                </a:solidFill>
+                <a:latin typeface="Arial" pitchFamily="34" charset="0"/>
+                <a:ea typeface="Arial" pitchFamily="34" charset="-122"/>
+                <a:cs typeface="Arial" pitchFamily="34" charset="-120"/>
+              </a:rPr>
+              <a:t>AGL FEED MANHOLE / HANDHOLE</a:t>
             </a:r>
             <a:endParaRPr lang="en-US" sz="740" dirty="0"/>
           </a:p>
@@ -24233,7 +24417,7 @@
         <p:spPr>
           <a:xfrm>
             <a:off x="10104120" y="6584594"/>
-            <a:ext cx="4709160" cy="2871216"/>
+            <a:ext cx="4709160" cy="3419856"/>
           </a:xfrm>
           <a:prstGeom prst="rect">
             <a:avLst/>
@@ -24625,6 +24809,68 @@
             <a:avLst/>
           </a:prstGeom>
           <a:noFill/>
+          <a:ln w="12700">
+            <a:solidFill>
+              <a:srgbClr val="C9CDD2"/>
+            </a:solidFill>
+            <a:prstDash val="dash"/>
+          </a:ln>
+        </p:spPr>
+      </p:sp>
+      <p:sp>
+        <p:nvSpPr>
+          <p:cNvPr id="325" name="Text 323"/>
+          <p:cNvSpPr/>
+          <p:nvPr/>
+        </p:nvSpPr>
+        <p:spPr>
+          <a:xfrm>
+            <a:off x="10616184" y="8065922"/>
+            <a:ext cx="4050792" cy="237744"/>
+          </a:xfrm>
+          <a:prstGeom prst="rect">
+            <a:avLst/>
+          </a:prstGeom>
+          <a:noFill/>
+          <a:ln/>
+        </p:spPr>
+        <p:txBody>
+          <a:bodyPr wrap="square" lIns="0" tIns="0" rIns="0" bIns="0" rtlCol="0" anchor="ctr"/>
+          <a:lstStyle/>
+          <a:p>
+            <a:pPr indent="0" marL="0">
+              <a:buNone/>
+            </a:pPr>
+            <a:r>
+              <a:rPr lang="en-US" sz="740" dirty="0">
+                <a:solidFill>
+                  <a:srgbClr val="1F2937"/>
+                </a:solidFill>
+                <a:latin typeface="Arial" pitchFamily="34" charset="0"/>
+                <a:ea typeface="Arial" pitchFamily="34" charset="-122"/>
+                <a:cs typeface="Arial" pitchFamily="34" charset="-120"/>
+              </a:rPr>
+              <a:t>INDICATIVE DUCT — LIGHT TO NEAREST MH/HH</a:t>
+            </a:r>
+            <a:endParaRPr lang="en-US" sz="740" dirty="0"/>
+          </a:p>
+        </p:txBody>
+      </p:sp>
+      <p:sp>
+        <p:nvSpPr>
+          <p:cNvPr id="326" name="Shape 324"/>
+          <p:cNvSpPr/>
+          <p:nvPr/>
+        </p:nvSpPr>
+        <p:spPr>
+          <a:xfrm>
+            <a:off x="10268712" y="8449970"/>
+            <a:ext cx="274320" cy="914"/>
+          </a:xfrm>
+          <a:prstGeom prst="line">
+            <a:avLst/>
+          </a:prstGeom>
+          <a:noFill/>
           <a:ln w="19050">
             <a:solidFill>
               <a:srgbClr val="BB00BB"/>
@@ -24635,13 +24881,13 @@
       </p:sp>
       <p:sp>
         <p:nvSpPr>
-          <p:cNvPr id="325" name="Text 323"/>
-          <p:cNvSpPr/>
-          <p:nvPr/>
-        </p:nvSpPr>
-        <p:spPr>
-          <a:xfrm>
-            <a:off x="10616184" y="8065922"/>
+          <p:cNvPr id="327" name="Text 325"/>
+          <p:cNvSpPr/>
+          <p:nvPr/>
+        </p:nvSpPr>
+        <p:spPr>
+          <a:xfrm>
+            <a:off x="10616184" y="8340242"/>
             <a:ext cx="4050792" cy="237744"/>
           </a:xfrm>
           <a:prstGeom prst="rect">
@@ -24674,13 +24920,13 @@
       </p:sp>
       <p:sp>
         <p:nvSpPr>
-          <p:cNvPr id="326" name="Shape 324"/>
-          <p:cNvSpPr/>
-          <p:nvPr/>
-        </p:nvSpPr>
-        <p:spPr>
-          <a:xfrm>
-            <a:off x="10268712" y="8449970"/>
+          <p:cNvPr id="328" name="Shape 326"/>
+          <p:cNvSpPr/>
+          <p:nvPr/>
+        </p:nvSpPr>
+        <p:spPr>
+          <a:xfrm>
+            <a:off x="10268712" y="8724290"/>
             <a:ext cx="274320" cy="914"/>
           </a:xfrm>
           <a:prstGeom prst="line">
@@ -24697,13 +24943,13 @@
       </p:sp>
       <p:sp>
         <p:nvSpPr>
-          <p:cNvPr id="327" name="Text 325"/>
-          <p:cNvSpPr/>
-          <p:nvPr/>
-        </p:nvSpPr>
-        <p:spPr>
-          <a:xfrm>
-            <a:off x="10616184" y="8340242"/>
+          <p:cNvPr id="329" name="Text 327"/>
+          <p:cNvSpPr/>
+          <p:nvPr/>
+        </p:nvSpPr>
+        <p:spPr>
+          <a:xfrm>
+            <a:off x="10616184" y="8614562"/>
             <a:ext cx="4050792" cy="237744"/>
           </a:xfrm>
           <a:prstGeom prst="rect">
@@ -24736,13 +24982,13 @@
       </p:sp>
       <p:sp>
         <p:nvSpPr>
-          <p:cNvPr id="328" name="Shape 326"/>
-          <p:cNvSpPr/>
-          <p:nvPr/>
-        </p:nvSpPr>
-        <p:spPr>
-          <a:xfrm>
-            <a:off x="10268712" y="8724290"/>
+          <p:cNvPr id="330" name="Shape 328"/>
+          <p:cNvSpPr/>
+          <p:nvPr/>
+        </p:nvSpPr>
+        <p:spPr>
+          <a:xfrm>
+            <a:off x="10268712" y="8998610"/>
             <a:ext cx="274320" cy="914"/>
           </a:xfrm>
           <a:prstGeom prst="line">
@@ -24759,13 +25005,13 @@
       </p:sp>
       <p:sp>
         <p:nvSpPr>
-          <p:cNvPr id="329" name="Text 327"/>
-          <p:cNvSpPr/>
-          <p:nvPr/>
-        </p:nvSpPr>
-        <p:spPr>
-          <a:xfrm>
-            <a:off x="10616184" y="8614562"/>
+          <p:cNvPr id="331" name="Text 329"/>
+          <p:cNvSpPr/>
+          <p:nvPr/>
+        </p:nvSpPr>
+        <p:spPr>
+          <a:xfrm>
+            <a:off x="10616184" y="8888882"/>
             <a:ext cx="4050792" cy="237744"/>
           </a:xfrm>
           <a:prstGeom prst="rect">
@@ -24798,13 +25044,13 @@
       </p:sp>
       <p:sp>
         <p:nvSpPr>
-          <p:cNvPr id="330" name="Shape 328"/>
-          <p:cNvSpPr/>
-          <p:nvPr/>
-        </p:nvSpPr>
-        <p:spPr>
-          <a:xfrm>
-            <a:off x="10268712" y="8998610"/>
+          <p:cNvPr id="332" name="Shape 330"/>
+          <p:cNvSpPr/>
+          <p:nvPr/>
+        </p:nvSpPr>
+        <p:spPr>
+          <a:xfrm>
+            <a:off x="10268712" y="9272930"/>
             <a:ext cx="274320" cy="914"/>
           </a:xfrm>
           <a:prstGeom prst="line">
@@ -24821,13 +25067,13 @@
       </p:sp>
       <p:sp>
         <p:nvSpPr>
-          <p:cNvPr id="331" name="Text 329"/>
-          <p:cNvSpPr/>
-          <p:nvPr/>
-        </p:nvSpPr>
-        <p:spPr>
-          <a:xfrm>
-            <a:off x="10616184" y="8888882"/>
+          <p:cNvPr id="333" name="Text 331"/>
+          <p:cNvSpPr/>
+          <p:nvPr/>
+        </p:nvSpPr>
+        <p:spPr>
+          <a:xfrm>
+            <a:off x="10616184" y="9163202"/>
             <a:ext cx="4050792" cy="237744"/>
           </a:xfrm>
           <a:prstGeom prst="rect">
@@ -24860,13 +25106,13 @@
       </p:sp>
       <p:sp>
         <p:nvSpPr>
-          <p:cNvPr id="332" name="Shape 330"/>
-          <p:cNvSpPr/>
-          <p:nvPr/>
-        </p:nvSpPr>
-        <p:spPr>
-          <a:xfrm>
-            <a:off x="10268712" y="9272930"/>
+          <p:cNvPr id="334" name="Shape 332"/>
+          <p:cNvSpPr/>
+          <p:nvPr/>
+        </p:nvSpPr>
+        <p:spPr>
+          <a:xfrm>
+            <a:off x="10268712" y="9547250"/>
             <a:ext cx="274320" cy="914"/>
           </a:xfrm>
           <a:prstGeom prst="line">
@@ -24883,13 +25129,13 @@
       </p:sp>
       <p:sp>
         <p:nvSpPr>
-          <p:cNvPr id="333" name="Text 331"/>
-          <p:cNvSpPr/>
-          <p:nvPr/>
-        </p:nvSpPr>
-        <p:spPr>
-          <a:xfrm>
-            <a:off x="10616184" y="9163202"/>
+          <p:cNvPr id="335" name="Text 333"/>
+          <p:cNvSpPr/>
+          <p:nvPr/>
+        </p:nvSpPr>
+        <p:spPr>
+          <a:xfrm>
+            <a:off x="10616184" y="9437522"/>
             <a:ext cx="4050792" cy="237744"/>
           </a:xfrm>
           <a:prstGeom prst="rect">
@@ -24915,6 +25161,67 @@
                 <a:cs typeface="Arial" pitchFamily="34" charset="-120"/>
               </a:rPr>
               <a:t>TWY EDGE / PAVEMENT BOUNDARY (INDICATIVE 23 m — CONFIRM ON SITE)</a:t>
+            </a:r>
+            <a:endParaRPr lang="en-US" sz="740" dirty="0"/>
+          </a:p>
+        </p:txBody>
+      </p:sp>
+      <p:sp>
+        <p:nvSpPr>
+          <p:cNvPr id="336" name="Shape 334"/>
+          <p:cNvSpPr/>
+          <p:nvPr/>
+        </p:nvSpPr>
+        <p:spPr>
+          <a:xfrm>
+            <a:off x="10287000" y="9739274"/>
+            <a:ext cx="219456" cy="146304"/>
+          </a:xfrm>
+          <a:prstGeom prst="rect">
+            <a:avLst/>
+          </a:prstGeom>
+          <a:ln w="19050">
+            <a:solidFill>
+              <a:srgbClr val="BB00BB"/>
+            </a:solidFill>
+            <a:prstDash val="solid"/>
+          </a:ln>
+        </p:spPr>
+      </p:sp>
+      <p:sp>
+        <p:nvSpPr>
+          <p:cNvPr id="337" name="Text 335"/>
+          <p:cNvSpPr/>
+          <p:nvPr/>
+        </p:nvSpPr>
+        <p:spPr>
+          <a:xfrm>
+            <a:off x="10616184" y="9711842"/>
+            <a:ext cx="4050792" cy="237744"/>
+          </a:xfrm>
+          <a:prstGeom prst="rect">
+            <a:avLst/>
+          </a:prstGeom>
+          <a:noFill/>
+          <a:ln/>
+        </p:spPr>
+        <p:txBody>
+          <a:bodyPr wrap="square" lIns="0" tIns="0" rIns="0" bIns="0" rtlCol="0" anchor="ctr"/>
+          <a:lstStyle/>
+          <a:p>
+            <a:pPr indent="0" marL="0">
+              <a:buNone/>
+            </a:pPr>
+            <a:r>
+              <a:rPr lang="en-US" sz="740" dirty="0">
+                <a:solidFill>
+                  <a:srgbClr val="1F2937"/>
+                </a:solidFill>
+                <a:latin typeface="Arial" pitchFamily="34" charset="0"/>
+                <a:ea typeface="Arial" pitchFamily="34" charset="-122"/>
+                <a:cs typeface="Arial" pitchFamily="34" charset="-120"/>
+              </a:rPr>
+              <a:t>AGL FEED MANHOLE / HANDHOLE</a:t>
             </a:r>
             <a:endParaRPr lang="en-US" sz="740" dirty="0"/>
           </a:p>

</xml_diff>

<commit_message>
Location 2: redraw secondary duct as chained edge-circuit run
Replaces the straight light-to-manhole indicative lines with the
field-confirmed chained route HH.E.056 > 03/007 > 04/007 > 03/008 >
04/008 > 03/009 > HH.E.054 plus a spur from HH.E.055, marked indicative
pending duct-layout CAD Rev B. Scope notes updated in all three formats.

Co-Authored-By: Claude Fable 5 <noreply@anthropic.com>
Claude-Session: https://claude.ai/code/session_01N2KftBqxVNP8RaeHWyv1DV
</commit_message>
<xml_diff>
--- a/projects/taxiway-e-agl-milling/drawings/TWY-E-AGL-SHOPDWG-EDITABLE_RevP05.pptx
+++ b/projects/taxiway-e-agl-milling/drawings/TWY-E-AGL-SHOPDWG-EDITABLE_RevP05.pptx
@@ -12498,29 +12498,6 @@
           <p:nvPr/>
         </p:nvSpPr>
         <p:spPr>
-          <a:xfrm>
-            <a:off x="2505033" y="2025670"/>
-            <a:ext cx="541217" cy="2381548"/>
-          </a:xfrm>
-          <a:prstGeom prst="line">
-            <a:avLst/>
-          </a:prstGeom>
-          <a:noFill/>
-          <a:ln w="9525">
-            <a:solidFill>
-              <a:srgbClr val="C9CDD2"/>
-            </a:solidFill>
-            <a:prstDash val="dash"/>
-          </a:ln>
-        </p:spPr>
-      </p:sp>
-      <p:sp>
-        <p:nvSpPr>
-          <p:cNvPr id="39" name="Shape 37"/>
-          <p:cNvSpPr/>
-          <p:nvPr/>
-        </p:nvSpPr>
-        <p:spPr>
           <a:xfrm flipV="1">
             <a:off x="2019761" y="2025670"/>
             <a:ext cx="485271" cy="1559200"/>
@@ -12539,7 +12516,7 @@
       </p:sp>
       <p:sp>
         <p:nvSpPr>
-          <p:cNvPr id="40" name="Shape 38"/>
+          <p:cNvPr id="39" name="Shape 37"/>
           <p:cNvSpPr/>
           <p:nvPr/>
         </p:nvSpPr>
@@ -12562,22 +12539,137 @@
       </p:sp>
       <p:sp>
         <p:nvSpPr>
+          <p:cNvPr id="40" name="Shape 38"/>
+          <p:cNvSpPr/>
+          <p:nvPr/>
+        </p:nvSpPr>
+        <p:spPr>
+          <a:xfrm flipV="1">
+            <a:off x="3046250" y="2670009"/>
+            <a:ext cx="1782193" cy="1737209"/>
+          </a:xfrm>
+          <a:prstGeom prst="line">
+            <a:avLst/>
+          </a:prstGeom>
+          <a:noFill/>
+          <a:ln w="19050">
+            <a:solidFill>
+              <a:srgbClr val="BB00BB"/>
+            </a:solidFill>
+            <a:prstDash val="dash"/>
+          </a:ln>
+        </p:spPr>
+      </p:sp>
+      <p:sp>
+        <p:nvSpPr>
           <p:cNvPr id="41" name="Shape 39"/>
           <p:cNvSpPr/>
           <p:nvPr/>
         </p:nvSpPr>
         <p:spPr>
           <a:xfrm>
+            <a:off x="3046250" y="4407218"/>
+            <a:ext cx="1024472" cy="823576"/>
+          </a:xfrm>
+          <a:prstGeom prst="line">
+            <a:avLst/>
+          </a:prstGeom>
+          <a:noFill/>
+          <a:ln w="19050">
+            <a:solidFill>
+              <a:srgbClr val="BB00BB"/>
+            </a:solidFill>
+            <a:prstDash val="dash"/>
+          </a:ln>
+        </p:spPr>
+      </p:sp>
+      <p:sp>
+        <p:nvSpPr>
+          <p:cNvPr id="42" name="Shape 40"/>
+          <p:cNvSpPr/>
+          <p:nvPr/>
+        </p:nvSpPr>
+        <p:spPr>
+          <a:xfrm>
+            <a:off x="4070722" y="5230793"/>
+            <a:ext cx="1026839" cy="825067"/>
+          </a:xfrm>
+          <a:prstGeom prst="line">
+            <a:avLst/>
+          </a:prstGeom>
+          <a:noFill/>
+          <a:ln w="19050">
+            <a:solidFill>
+              <a:srgbClr val="BB00BB"/>
+            </a:solidFill>
+            <a:prstDash val="dash"/>
+          </a:ln>
+        </p:spPr>
+      </p:sp>
+      <p:sp>
+        <p:nvSpPr>
+          <p:cNvPr id="43" name="Shape 41"/>
+          <p:cNvSpPr/>
+          <p:nvPr/>
+        </p:nvSpPr>
+        <p:spPr>
+          <a:xfrm>
+            <a:off x="5097561" y="6055860"/>
+            <a:ext cx="1027015" cy="823313"/>
+          </a:xfrm>
+          <a:prstGeom prst="line">
+            <a:avLst/>
+          </a:prstGeom>
+          <a:noFill/>
+          <a:ln w="19050">
+            <a:solidFill>
+              <a:srgbClr val="BB00BB"/>
+            </a:solidFill>
+            <a:prstDash val="dash"/>
+          </a:ln>
+        </p:spPr>
+      </p:sp>
+      <p:sp>
+        <p:nvSpPr>
+          <p:cNvPr id="44" name="Shape 42"/>
+          <p:cNvSpPr/>
+          <p:nvPr/>
+        </p:nvSpPr>
+        <p:spPr>
+          <a:xfrm>
+            <a:off x="6124575" y="6879173"/>
+            <a:ext cx="1024735" cy="822874"/>
+          </a:xfrm>
+          <a:prstGeom prst="line">
+            <a:avLst/>
+          </a:prstGeom>
+          <a:noFill/>
+          <a:ln w="19050">
+            <a:solidFill>
+              <a:srgbClr val="BB00BB"/>
+            </a:solidFill>
+            <a:prstDash val="dash"/>
+          </a:ln>
+        </p:spPr>
+      </p:sp>
+      <p:sp>
+        <p:nvSpPr>
+          <p:cNvPr id="45" name="Shape 43"/>
+          <p:cNvSpPr/>
+          <p:nvPr/>
+        </p:nvSpPr>
+        <p:spPr>
+          <a:xfrm>
             <a:off x="7149310" y="7702047"/>
-            <a:ext cx="2630673" cy="446077"/>
+            <a:ext cx="2630673" cy="110925"/>
           </a:xfrm>
           <a:prstGeom prst="line">
             <a:avLst/>
           </a:prstGeom>
           <a:noFill/>
-          <a:ln w="9525">
-            <a:solidFill>
-              <a:srgbClr val="C9CDD2"/>
+          <a:ln w="19050">
+            <a:solidFill>
+              <a:srgbClr val="BB00BB"/>
             </a:solidFill>
             <a:prstDash val="dash"/>
           </a:ln>
@@ -12585,14 +12677,14 @@
       </p:sp>
       <p:sp>
         <p:nvSpPr>
-          <p:cNvPr id="42" name="Shape 40"/>
+          <p:cNvPr id="46" name="Shape 44"/>
           <p:cNvSpPr/>
           <p:nvPr/>
         </p:nvSpPr>
         <p:spPr>
           <a:xfrm flipV="1">
-            <a:off x="4070722" y="4187030"/>
-            <a:ext cx="1528947" cy="1043763"/>
+            <a:off x="4070722" y="3729293"/>
+            <a:ext cx="1905045" cy="1501500"/>
           </a:xfrm>
           <a:prstGeom prst="line">
             <a:avLst/>
@@ -12608,53 +12700,7 @@
       </p:sp>
       <p:sp>
         <p:nvSpPr>
-          <p:cNvPr id="43" name="Shape 41"/>
-          <p:cNvSpPr/>
-          <p:nvPr/>
-        </p:nvSpPr>
-        <p:spPr>
-          <a:xfrm flipV="1">
-            <a:off x="5097561" y="4187030"/>
-            <a:ext cx="502108" cy="1868830"/>
-          </a:xfrm>
-          <a:prstGeom prst="line">
-            <a:avLst/>
-          </a:prstGeom>
-          <a:noFill/>
-          <a:ln w="19050">
-            <a:solidFill>
-              <a:srgbClr val="BB00BB"/>
-            </a:solidFill>
-            <a:prstDash val="dash"/>
-          </a:ln>
-        </p:spPr>
-      </p:sp>
-      <p:sp>
-        <p:nvSpPr>
-          <p:cNvPr id="44" name="Shape 42"/>
-          <p:cNvSpPr/>
-          <p:nvPr/>
-        </p:nvSpPr>
-        <p:spPr>
-          <a:xfrm>
-            <a:off x="5599668" y="4187030"/>
-            <a:ext cx="524907" cy="2692143"/>
-          </a:xfrm>
-          <a:prstGeom prst="line">
-            <a:avLst/>
-          </a:prstGeom>
-          <a:noFill/>
-          <a:ln w="19050">
-            <a:solidFill>
-              <a:srgbClr val="BB00BB"/>
-            </a:solidFill>
-            <a:prstDash val="dash"/>
-          </a:ln>
-        </p:spPr>
-      </p:sp>
-      <p:sp>
-        <p:nvSpPr>
-          <p:cNvPr id="45" name="Shape 43"/>
+          <p:cNvPr id="47" name="Shape 45"/>
           <p:cNvSpPr/>
           <p:nvPr/>
         </p:nvSpPr>
@@ -12676,7 +12722,7 @@
       </p:sp>
       <p:sp>
         <p:nvSpPr>
-          <p:cNvPr id="46" name="Text 44"/>
+          <p:cNvPr id="48" name="Text 46"/>
           <p:cNvSpPr/>
           <p:nvPr/>
         </p:nvSpPr>
@@ -12715,7 +12761,7 @@
       </p:sp>
       <p:sp>
         <p:nvSpPr>
-          <p:cNvPr id="47" name="Shape 45"/>
+          <p:cNvPr id="49" name="Shape 47"/>
           <p:cNvSpPr/>
           <p:nvPr/>
         </p:nvSpPr>
@@ -12738,7 +12784,7 @@
       </p:sp>
       <p:sp>
         <p:nvSpPr>
-          <p:cNvPr id="48" name="Shape 46"/>
+          <p:cNvPr id="50" name="Shape 48"/>
           <p:cNvSpPr/>
           <p:nvPr/>
         </p:nvSpPr>
@@ -12761,7 +12807,7 @@
       </p:sp>
       <p:sp>
         <p:nvSpPr>
-          <p:cNvPr id="49" name="Shape 47"/>
+          <p:cNvPr id="51" name="Shape 49"/>
           <p:cNvSpPr/>
           <p:nvPr/>
         </p:nvSpPr>
@@ -12784,7 +12830,7 @@
       </p:sp>
       <p:sp>
         <p:nvSpPr>
-          <p:cNvPr id="50" name="Shape 48"/>
+          <p:cNvPr id="52" name="Shape 50"/>
           <p:cNvSpPr/>
           <p:nvPr/>
         </p:nvSpPr>
@@ -12807,7 +12853,7 @@
       </p:sp>
       <p:sp>
         <p:nvSpPr>
-          <p:cNvPr id="51" name="Text 49"/>
+          <p:cNvPr id="53" name="Text 51"/>
           <p:cNvSpPr/>
           <p:nvPr/>
         </p:nvSpPr>
@@ -12846,7 +12892,7 @@
       </p:sp>
       <p:sp>
         <p:nvSpPr>
-          <p:cNvPr id="52" name="Shape 50"/>
+          <p:cNvPr id="54" name="Shape 52"/>
           <p:cNvSpPr/>
           <p:nvPr/>
         </p:nvSpPr>
@@ -12871,7 +12917,7 @@
       </p:sp>
       <p:sp>
         <p:nvSpPr>
-          <p:cNvPr id="53" name="Shape 51"/>
+          <p:cNvPr id="55" name="Shape 53"/>
           <p:cNvSpPr/>
           <p:nvPr/>
         </p:nvSpPr>
@@ -12896,7 +12942,7 @@
       </p:sp>
       <p:sp>
         <p:nvSpPr>
-          <p:cNvPr id="54" name="Shape 52"/>
+          <p:cNvPr id="56" name="Shape 54"/>
           <p:cNvSpPr/>
           <p:nvPr/>
         </p:nvSpPr>
@@ -12921,7 +12967,7 @@
       </p:sp>
       <p:sp>
         <p:nvSpPr>
-          <p:cNvPr id="55" name="Shape 53"/>
+          <p:cNvPr id="57" name="Shape 55"/>
           <p:cNvSpPr/>
           <p:nvPr/>
         </p:nvSpPr>
@@ -12946,7 +12992,7 @@
       </p:sp>
       <p:sp>
         <p:nvSpPr>
-          <p:cNvPr id="56" name="Shape 54"/>
+          <p:cNvPr id="58" name="Shape 56"/>
           <p:cNvSpPr/>
           <p:nvPr/>
         </p:nvSpPr>
@@ -12971,7 +13017,7 @@
       </p:sp>
       <p:sp>
         <p:nvSpPr>
-          <p:cNvPr id="57" name="Shape 55"/>
+          <p:cNvPr id="59" name="Shape 57"/>
           <p:cNvSpPr/>
           <p:nvPr/>
         </p:nvSpPr>
@@ -12996,7 +13042,7 @@
       </p:sp>
       <p:sp>
         <p:nvSpPr>
-          <p:cNvPr id="58" name="Shape 56"/>
+          <p:cNvPr id="60" name="Shape 58"/>
           <p:cNvSpPr/>
           <p:nvPr/>
         </p:nvSpPr>
@@ -13021,7 +13067,7 @@
       </p:sp>
       <p:sp>
         <p:nvSpPr>
-          <p:cNvPr id="59" name="Shape 57"/>
+          <p:cNvPr id="61" name="Shape 59"/>
           <p:cNvSpPr/>
           <p:nvPr/>
         </p:nvSpPr>
@@ -13046,7 +13092,7 @@
       </p:sp>
       <p:sp>
         <p:nvSpPr>
-          <p:cNvPr id="60" name="Shape 58"/>
+          <p:cNvPr id="62" name="Shape 60"/>
           <p:cNvSpPr/>
           <p:nvPr/>
         </p:nvSpPr>
@@ -13071,7 +13117,7 @@
       </p:sp>
       <p:sp>
         <p:nvSpPr>
-          <p:cNvPr id="61" name="Shape 59"/>
+          <p:cNvPr id="63" name="Shape 61"/>
           <p:cNvSpPr/>
           <p:nvPr/>
         </p:nvSpPr>
@@ -13096,7 +13142,7 @@
       </p:sp>
       <p:sp>
         <p:nvSpPr>
-          <p:cNvPr id="62" name="Shape 60"/>
+          <p:cNvPr id="64" name="Shape 62"/>
           <p:cNvSpPr/>
           <p:nvPr/>
         </p:nvSpPr>
@@ -13121,7 +13167,7 @@
       </p:sp>
       <p:sp>
         <p:nvSpPr>
-          <p:cNvPr id="63" name="Shape 61"/>
+          <p:cNvPr id="65" name="Shape 63"/>
           <p:cNvSpPr/>
           <p:nvPr/>
         </p:nvSpPr>
@@ -13146,7 +13192,7 @@
       </p:sp>
       <p:sp>
         <p:nvSpPr>
-          <p:cNvPr id="64" name="Shape 62"/>
+          <p:cNvPr id="66" name="Shape 64"/>
           <p:cNvSpPr/>
           <p:nvPr/>
         </p:nvSpPr>
@@ -13171,7 +13217,7 @@
       </p:sp>
       <p:sp>
         <p:nvSpPr>
-          <p:cNvPr id="65" name="Shape 63"/>
+          <p:cNvPr id="67" name="Shape 65"/>
           <p:cNvSpPr/>
           <p:nvPr/>
         </p:nvSpPr>
@@ -13196,7 +13242,7 @@
       </p:sp>
       <p:sp>
         <p:nvSpPr>
-          <p:cNvPr id="66" name="Shape 64"/>
+          <p:cNvPr id="68" name="Shape 66"/>
           <p:cNvSpPr/>
           <p:nvPr/>
         </p:nvSpPr>
@@ -13221,7 +13267,7 @@
       </p:sp>
       <p:sp>
         <p:nvSpPr>
-          <p:cNvPr id="67" name="Shape 65"/>
+          <p:cNvPr id="69" name="Shape 67"/>
           <p:cNvSpPr/>
           <p:nvPr/>
         </p:nvSpPr>
@@ -13246,7 +13292,7 @@
       </p:sp>
       <p:sp>
         <p:nvSpPr>
-          <p:cNvPr id="68" name="Shape 66"/>
+          <p:cNvPr id="70" name="Shape 68"/>
           <p:cNvSpPr/>
           <p:nvPr/>
         </p:nvSpPr>
@@ -13271,7 +13317,7 @@
       </p:sp>
       <p:sp>
         <p:nvSpPr>
-          <p:cNvPr id="69" name="Text 67"/>
+          <p:cNvPr id="71" name="Text 69"/>
           <p:cNvSpPr/>
           <p:nvPr/>
         </p:nvSpPr>
@@ -13310,7 +13356,7 @@
       </p:sp>
       <p:sp>
         <p:nvSpPr>
-          <p:cNvPr id="70" name="Text 68"/>
+          <p:cNvPr id="72" name="Text 70"/>
           <p:cNvSpPr/>
           <p:nvPr/>
         </p:nvSpPr>
@@ -13349,7 +13395,7 @@
       </p:sp>
       <p:sp>
         <p:nvSpPr>
-          <p:cNvPr id="71" name="Text 69"/>
+          <p:cNvPr id="73" name="Text 71"/>
           <p:cNvSpPr/>
           <p:nvPr/>
         </p:nvSpPr>
@@ -13388,7 +13434,7 @@
       </p:sp>
       <p:sp>
         <p:nvSpPr>
-          <p:cNvPr id="72" name="Text 70"/>
+          <p:cNvPr id="74" name="Text 72"/>
           <p:cNvSpPr/>
           <p:nvPr/>
         </p:nvSpPr>
@@ -13427,7 +13473,7 @@
       </p:sp>
       <p:sp>
         <p:nvSpPr>
-          <p:cNvPr id="73" name="Text 71"/>
+          <p:cNvPr id="75" name="Text 73"/>
           <p:cNvSpPr/>
           <p:nvPr/>
         </p:nvSpPr>
@@ -13466,7 +13512,7 @@
       </p:sp>
       <p:sp>
         <p:nvSpPr>
-          <p:cNvPr id="74" name="Text 72"/>
+          <p:cNvPr id="76" name="Text 74"/>
           <p:cNvSpPr/>
           <p:nvPr/>
         </p:nvSpPr>
@@ -13505,7 +13551,7 @@
       </p:sp>
       <p:sp>
         <p:nvSpPr>
-          <p:cNvPr id="75" name="Text 73"/>
+          <p:cNvPr id="77" name="Text 75"/>
           <p:cNvSpPr/>
           <p:nvPr/>
         </p:nvSpPr>
@@ -13544,7 +13590,7 @@
       </p:sp>
       <p:sp>
         <p:nvSpPr>
-          <p:cNvPr id="76" name="Text 74"/>
+          <p:cNvPr id="78" name="Text 76"/>
           <p:cNvSpPr/>
           <p:nvPr/>
         </p:nvSpPr>
@@ -13583,7 +13629,7 @@
       </p:sp>
       <p:sp>
         <p:nvSpPr>
-          <p:cNvPr id="77" name="Text 75"/>
+          <p:cNvPr id="79" name="Text 77"/>
           <p:cNvSpPr/>
           <p:nvPr/>
         </p:nvSpPr>
@@ -13622,7 +13668,7 @@
       </p:sp>
       <p:sp>
         <p:nvSpPr>
-          <p:cNvPr id="78" name="Text 76"/>
+          <p:cNvPr id="80" name="Text 78"/>
           <p:cNvSpPr/>
           <p:nvPr/>
         </p:nvSpPr>
@@ -13661,7 +13707,7 @@
       </p:sp>
       <p:sp>
         <p:nvSpPr>
-          <p:cNvPr id="79" name="Text 77"/>
+          <p:cNvPr id="81" name="Text 79"/>
           <p:cNvSpPr/>
           <p:nvPr/>
         </p:nvSpPr>
@@ -13700,7 +13746,7 @@
       </p:sp>
       <p:sp>
         <p:nvSpPr>
-          <p:cNvPr id="80" name="Text 78"/>
+          <p:cNvPr id="82" name="Text 80"/>
           <p:cNvSpPr/>
           <p:nvPr/>
         </p:nvSpPr>
@@ -13739,7 +13785,7 @@
       </p:sp>
       <p:sp>
         <p:nvSpPr>
-          <p:cNvPr id="81" name="Text 79"/>
+          <p:cNvPr id="83" name="Text 81"/>
           <p:cNvSpPr/>
           <p:nvPr/>
         </p:nvSpPr>
@@ -13778,7 +13824,7 @@
       </p:sp>
       <p:sp>
         <p:nvSpPr>
-          <p:cNvPr id="82" name="Text 80"/>
+          <p:cNvPr id="84" name="Text 82"/>
           <p:cNvSpPr/>
           <p:nvPr/>
         </p:nvSpPr>
@@ -13817,7 +13863,7 @@
       </p:sp>
       <p:sp>
         <p:nvSpPr>
-          <p:cNvPr id="83" name="Text 81"/>
+          <p:cNvPr id="85" name="Text 83"/>
           <p:cNvSpPr/>
           <p:nvPr/>
         </p:nvSpPr>
@@ -13856,7 +13902,7 @@
       </p:sp>
       <p:sp>
         <p:nvSpPr>
-          <p:cNvPr id="84" name="Text 82"/>
+          <p:cNvPr id="86" name="Text 84"/>
           <p:cNvSpPr/>
           <p:nvPr/>
         </p:nvSpPr>
@@ -13895,7 +13941,7 @@
       </p:sp>
       <p:sp>
         <p:nvSpPr>
-          <p:cNvPr id="85" name="Text 83"/>
+          <p:cNvPr id="87" name="Text 85"/>
           <p:cNvSpPr/>
           <p:nvPr/>
         </p:nvSpPr>
@@ -13934,7 +13980,7 @@
       </p:sp>
       <p:sp>
         <p:nvSpPr>
-          <p:cNvPr id="86" name="Shape 84"/>
+          <p:cNvPr id="88" name="Shape 86"/>
           <p:cNvSpPr/>
           <p:nvPr/>
         </p:nvSpPr>
@@ -13956,7 +14002,7 @@
       </p:sp>
       <p:sp>
         <p:nvSpPr>
-          <p:cNvPr id="87" name="Shape 85"/>
+          <p:cNvPr id="89" name="Shape 87"/>
           <p:cNvSpPr/>
           <p:nvPr/>
         </p:nvSpPr>
@@ -13981,7 +14027,7 @@
       </p:sp>
       <p:sp>
         <p:nvSpPr>
-          <p:cNvPr id="88" name="Text 86"/>
+          <p:cNvPr id="90" name="Text 88"/>
           <p:cNvSpPr/>
           <p:nvPr/>
         </p:nvSpPr>
@@ -14020,7 +14066,7 @@
       </p:sp>
       <p:sp>
         <p:nvSpPr>
-          <p:cNvPr id="89" name="Shape 87"/>
+          <p:cNvPr id="91" name="Shape 89"/>
           <p:cNvSpPr/>
           <p:nvPr/>
         </p:nvSpPr>
@@ -14042,7 +14088,7 @@
       </p:sp>
       <p:sp>
         <p:nvSpPr>
-          <p:cNvPr id="90" name="Shape 88"/>
+          <p:cNvPr id="92" name="Shape 90"/>
           <p:cNvSpPr/>
           <p:nvPr/>
         </p:nvSpPr>
@@ -14067,7 +14113,7 @@
       </p:sp>
       <p:sp>
         <p:nvSpPr>
-          <p:cNvPr id="91" name="Text 89"/>
+          <p:cNvPr id="93" name="Text 91"/>
           <p:cNvSpPr/>
           <p:nvPr/>
         </p:nvSpPr>
@@ -14106,7 +14152,7 @@
       </p:sp>
       <p:sp>
         <p:nvSpPr>
-          <p:cNvPr id="92" name="Shape 90"/>
+          <p:cNvPr id="94" name="Shape 92"/>
           <p:cNvSpPr/>
           <p:nvPr/>
         </p:nvSpPr>
@@ -14128,7 +14174,7 @@
       </p:sp>
       <p:sp>
         <p:nvSpPr>
-          <p:cNvPr id="93" name="Shape 91"/>
+          <p:cNvPr id="95" name="Shape 93"/>
           <p:cNvSpPr/>
           <p:nvPr/>
         </p:nvSpPr>
@@ -14153,7 +14199,7 @@
       </p:sp>
       <p:sp>
         <p:nvSpPr>
-          <p:cNvPr id="94" name="Text 92"/>
+          <p:cNvPr id="96" name="Text 94"/>
           <p:cNvSpPr/>
           <p:nvPr/>
         </p:nvSpPr>
@@ -14192,7 +14238,7 @@
       </p:sp>
       <p:sp>
         <p:nvSpPr>
-          <p:cNvPr id="95" name="Shape 93"/>
+          <p:cNvPr id="97" name="Shape 95"/>
           <p:cNvSpPr/>
           <p:nvPr/>
         </p:nvSpPr>
@@ -14214,7 +14260,7 @@
       </p:sp>
       <p:sp>
         <p:nvSpPr>
-          <p:cNvPr id="96" name="Shape 94"/>
+          <p:cNvPr id="98" name="Shape 96"/>
           <p:cNvSpPr/>
           <p:nvPr/>
         </p:nvSpPr>
@@ -14239,7 +14285,7 @@
       </p:sp>
       <p:sp>
         <p:nvSpPr>
-          <p:cNvPr id="97" name="Text 95"/>
+          <p:cNvPr id="99" name="Text 97"/>
           <p:cNvSpPr/>
           <p:nvPr/>
         </p:nvSpPr>
@@ -14278,7 +14324,7 @@
       </p:sp>
       <p:sp>
         <p:nvSpPr>
-          <p:cNvPr id="98" name="Shape 96"/>
+          <p:cNvPr id="100" name="Shape 98"/>
           <p:cNvSpPr/>
           <p:nvPr/>
         </p:nvSpPr>
@@ -14300,7 +14346,7 @@
       </p:sp>
       <p:sp>
         <p:nvSpPr>
-          <p:cNvPr id="99" name="Shape 97"/>
+          <p:cNvPr id="101" name="Shape 99"/>
           <p:cNvSpPr/>
           <p:nvPr/>
         </p:nvSpPr>
@@ -14325,7 +14371,7 @@
       </p:sp>
       <p:sp>
         <p:nvSpPr>
-          <p:cNvPr id="100" name="Text 98"/>
+          <p:cNvPr id="102" name="Text 100"/>
           <p:cNvSpPr/>
           <p:nvPr/>
         </p:nvSpPr>
@@ -14364,7 +14410,7 @@
       </p:sp>
       <p:sp>
         <p:nvSpPr>
-          <p:cNvPr id="101" name="Shape 99"/>
+          <p:cNvPr id="103" name="Shape 101"/>
           <p:cNvSpPr/>
           <p:nvPr/>
         </p:nvSpPr>
@@ -14386,7 +14432,7 @@
       </p:sp>
       <p:sp>
         <p:nvSpPr>
-          <p:cNvPr id="102" name="Shape 100"/>
+          <p:cNvPr id="104" name="Shape 102"/>
           <p:cNvSpPr/>
           <p:nvPr/>
         </p:nvSpPr>
@@ -14411,7 +14457,7 @@
       </p:sp>
       <p:sp>
         <p:nvSpPr>
-          <p:cNvPr id="103" name="Text 101"/>
+          <p:cNvPr id="105" name="Text 103"/>
           <p:cNvSpPr/>
           <p:nvPr/>
         </p:nvSpPr>
@@ -14450,7 +14496,7 @@
       </p:sp>
       <p:sp>
         <p:nvSpPr>
-          <p:cNvPr id="104" name="Shape 102"/>
+          <p:cNvPr id="106" name="Shape 104"/>
           <p:cNvSpPr/>
           <p:nvPr/>
         </p:nvSpPr>
@@ -14475,7 +14521,7 @@
       </p:sp>
       <p:sp>
         <p:nvSpPr>
-          <p:cNvPr id="105" name="Text 103"/>
+          <p:cNvPr id="107" name="Text 105"/>
           <p:cNvSpPr/>
           <p:nvPr/>
         </p:nvSpPr>
@@ -14514,7 +14560,7 @@
       </p:sp>
       <p:sp>
         <p:nvSpPr>
-          <p:cNvPr id="106" name="Text 104"/>
+          <p:cNvPr id="108" name="Text 106"/>
           <p:cNvSpPr/>
           <p:nvPr/>
         </p:nvSpPr>
@@ -14553,7 +14599,7 @@
       </p:sp>
       <p:sp>
         <p:nvSpPr>
-          <p:cNvPr id="107" name="Text 105"/>
+          <p:cNvPr id="109" name="Text 107"/>
           <p:cNvSpPr/>
           <p:nvPr/>
         </p:nvSpPr>
@@ -14592,14 +14638,14 @@
       </p:sp>
       <p:sp>
         <p:nvSpPr>
-          <p:cNvPr id="108" name="Shape 106"/>
+          <p:cNvPr id="110" name="Shape 108"/>
           <p:cNvSpPr/>
           <p:nvPr/>
         </p:nvSpPr>
         <p:spPr>
           <a:xfrm>
             <a:off x="10104120" y="2057400"/>
-            <a:ext cx="4709160" cy="1577340"/>
+            <a:ext cx="4709160" cy="2040026"/>
           </a:xfrm>
           <a:prstGeom prst="rect">
             <a:avLst/>
@@ -14617,7 +14663,7 @@
       </p:sp>
       <p:sp>
         <p:nvSpPr>
-          <p:cNvPr id="109" name="Text 107"/>
+          <p:cNvPr id="111" name="Text 109"/>
           <p:cNvSpPr/>
           <p:nvPr/>
         </p:nvSpPr>
@@ -14656,14 +14702,14 @@
       </p:sp>
       <p:sp>
         <p:nvSpPr>
-          <p:cNvPr id="110" name="Text 108"/>
+          <p:cNvPr id="112" name="Text 110"/>
           <p:cNvSpPr/>
           <p:nvPr/>
         </p:nvSpPr>
         <p:spPr>
           <a:xfrm>
             <a:off x="10241280" y="2386584"/>
-            <a:ext cx="4434840" cy="1193292"/>
+            <a:ext cx="4434840" cy="1655978"/>
           </a:xfrm>
           <a:prstGeom prst="rect">
             <a:avLst/>
@@ -14750,6 +14796,46 @@
                 <a:ea typeface="Arial" pitchFamily="34" charset="-122"/>
                 <a:cs typeface="Arial" pitchFamily="34" charset="-120"/>
               </a:rPr>
+              <a:t>SECONDARY DUCT: CHAINED RUN HH.E.056 → 03/007 → 04/007 → 03/008 → 04/008 → 03/009 → HH.E.054</a:t>
+            </a:r>
+            <a:endParaRPr lang="en-US" sz="760" dirty="0"/>
+          </a:p>
+          <a:p>
+            <a:pPr indent="0" marL="0">
+              <a:lnSpc>
+                <a:spcPct val="112000"/>
+              </a:lnSpc>
+              <a:buNone/>
+            </a:pPr>
+            <a:r>
+              <a:rPr lang="en-US" sz="760" dirty="0">
+                <a:solidFill>
+                  <a:srgbClr val="1F2937"/>
+                </a:solidFill>
+                <a:latin typeface="Arial" pitchFamily="34" charset="0"/>
+                <a:ea typeface="Arial" pitchFamily="34" charset="-122"/>
+                <a:cs typeface="Arial" pitchFamily="34" charset="-120"/>
+              </a:rPr>
+              <a:t>   + SPUR FROM HH.E.055 — INDICATIVE, CONFIRM VS DUCT-LAYOUT CAD (REV B)</a:t>
+            </a:r>
+            <a:endParaRPr lang="en-US" sz="760" dirty="0"/>
+          </a:p>
+          <a:p>
+            <a:pPr indent="0" marL="0">
+              <a:lnSpc>
+                <a:spcPct val="112000"/>
+              </a:lnSpc>
+              <a:buNone/>
+            </a:pPr>
+            <a:r>
+              <a:rPr lang="en-US" sz="760" dirty="0">
+                <a:solidFill>
+                  <a:srgbClr val="1F2937"/>
+                </a:solidFill>
+                <a:latin typeface="Arial" pitchFamily="34" charset="0"/>
+                <a:ea typeface="Arial" pitchFamily="34" charset="-122"/>
+                <a:cs typeface="Arial" pitchFamily="34" charset="-120"/>
+              </a:rPr>
               <a:t>RRM.555 (0.41 m from cut): REMOVE / PROTECT BEFORE SAWCUT, RE-FIX AFTER PAVING</a:t>
             </a:r>
             <a:endParaRPr lang="en-US" sz="760" dirty="0"/>
@@ -14778,13 +14864,13 @@
       </p:sp>
       <p:sp>
         <p:nvSpPr>
-          <p:cNvPr id="111" name="Shape 109"/>
-          <p:cNvSpPr/>
-          <p:nvPr/>
-        </p:nvSpPr>
-        <p:spPr>
-          <a:xfrm>
-            <a:off x="10104120" y="3744468"/>
+          <p:cNvPr id="113" name="Shape 111"/>
+          <p:cNvSpPr/>
+          <p:nvPr/>
+        </p:nvSpPr>
+        <p:spPr>
+          <a:xfrm>
+            <a:off x="10104120" y="4207154"/>
             <a:ext cx="4709160" cy="2267712"/>
           </a:xfrm>
           <a:prstGeom prst="rect">
@@ -14803,13 +14889,13 @@
       </p:sp>
       <p:sp>
         <p:nvSpPr>
-          <p:cNvPr id="112" name="Text 110"/>
-          <p:cNvSpPr/>
-          <p:nvPr/>
-        </p:nvSpPr>
-        <p:spPr>
-          <a:xfrm>
-            <a:off x="10241280" y="3817620"/>
+          <p:cNvPr id="114" name="Text 112"/>
+          <p:cNvSpPr/>
+          <p:nvPr/>
+        </p:nvSpPr>
+        <p:spPr>
+          <a:xfrm>
+            <a:off x="10241280" y="4280306"/>
             <a:ext cx="4434840" cy="219456"/>
           </a:xfrm>
           <a:prstGeom prst="rect">
@@ -14842,13 +14928,13 @@
       </p:sp>
       <p:sp>
         <p:nvSpPr>
-          <p:cNvPr id="113" name="Text 111"/>
-          <p:cNvSpPr/>
-          <p:nvPr/>
-        </p:nvSpPr>
-        <p:spPr>
-          <a:xfrm>
-            <a:off x="10241280" y="4073652"/>
+          <p:cNvPr id="115" name="Text 113"/>
+          <p:cNvSpPr/>
+          <p:nvPr/>
+        </p:nvSpPr>
+        <p:spPr>
+          <a:xfrm>
+            <a:off x="10241280" y="4536338"/>
             <a:ext cx="4434840" cy="1883664"/>
           </a:xfrm>
           <a:prstGeom prst="rect">
@@ -14984,13 +15070,13 @@
       </p:sp>
       <p:sp>
         <p:nvSpPr>
-          <p:cNvPr id="114" name="Shape 112"/>
-          <p:cNvSpPr/>
-          <p:nvPr/>
-        </p:nvSpPr>
-        <p:spPr>
-          <a:xfrm>
-            <a:off x="10104120" y="6121908"/>
+          <p:cNvPr id="116" name="Shape 114"/>
+          <p:cNvSpPr/>
+          <p:nvPr/>
+        </p:nvSpPr>
+        <p:spPr>
+          <a:xfrm>
+            <a:off x="10104120" y="6584594"/>
             <a:ext cx="4709160" cy="2871216"/>
           </a:xfrm>
           <a:prstGeom prst="rect">
@@ -15009,13 +15095,13 @@
       </p:sp>
       <p:sp>
         <p:nvSpPr>
-          <p:cNvPr id="115" name="Text 113"/>
-          <p:cNvSpPr/>
-          <p:nvPr/>
-        </p:nvSpPr>
-        <p:spPr>
-          <a:xfrm>
-            <a:off x="10241280" y="6195060"/>
+          <p:cNvPr id="117" name="Text 115"/>
+          <p:cNvSpPr/>
+          <p:nvPr/>
+        </p:nvSpPr>
+        <p:spPr>
+          <a:xfrm>
+            <a:off x="10241280" y="6657746"/>
             <a:ext cx="4434840" cy="219456"/>
           </a:xfrm>
           <a:prstGeom prst="rect">
@@ -15048,13 +15134,13 @@
       </p:sp>
       <p:sp>
         <p:nvSpPr>
-          <p:cNvPr id="116" name="Shape 114"/>
-          <p:cNvSpPr/>
-          <p:nvPr/>
-        </p:nvSpPr>
-        <p:spPr>
-          <a:xfrm>
-            <a:off x="10305288" y="6519672"/>
+          <p:cNvPr id="118" name="Shape 116"/>
+          <p:cNvSpPr/>
+          <p:nvPr/>
+        </p:nvSpPr>
+        <p:spPr>
+          <a:xfrm>
+            <a:off x="10305288" y="6982358"/>
             <a:ext cx="192024" cy="192024"/>
           </a:xfrm>
           <a:prstGeom prst="ellipse">
@@ -15070,13 +15156,13 @@
       </p:sp>
       <p:sp>
         <p:nvSpPr>
-          <p:cNvPr id="117" name="Shape 115"/>
-          <p:cNvSpPr/>
-          <p:nvPr/>
-        </p:nvSpPr>
-        <p:spPr>
-          <a:xfrm>
-            <a:off x="10351008" y="6565392"/>
+          <p:cNvPr id="119" name="Shape 117"/>
+          <p:cNvSpPr/>
+          <p:nvPr/>
+        </p:nvSpPr>
+        <p:spPr>
+          <a:xfrm>
+            <a:off x="10351008" y="7028078"/>
             <a:ext cx="100584" cy="100584"/>
           </a:xfrm>
           <a:prstGeom prst="ellipse">
@@ -15095,13 +15181,13 @@
       </p:sp>
       <p:sp>
         <p:nvSpPr>
-          <p:cNvPr id="118" name="Text 116"/>
-          <p:cNvSpPr/>
-          <p:nvPr/>
-        </p:nvSpPr>
-        <p:spPr>
-          <a:xfrm>
-            <a:off x="10616184" y="6505956"/>
+          <p:cNvPr id="120" name="Text 118"/>
+          <p:cNvSpPr/>
+          <p:nvPr/>
+        </p:nvSpPr>
+        <p:spPr>
+          <a:xfrm>
+            <a:off x="10616184" y="6968642"/>
             <a:ext cx="4050792" cy="237744"/>
           </a:xfrm>
           <a:prstGeom prst="rect">
@@ -15134,13 +15220,13 @@
       </p:sp>
       <p:sp>
         <p:nvSpPr>
-          <p:cNvPr id="119" name="Shape 117"/>
-          <p:cNvSpPr/>
-          <p:nvPr/>
-        </p:nvSpPr>
-        <p:spPr>
-          <a:xfrm>
-            <a:off x="10305288" y="6793992"/>
+          <p:cNvPr id="121" name="Shape 119"/>
+          <p:cNvSpPr/>
+          <p:nvPr/>
+        </p:nvSpPr>
+        <p:spPr>
+          <a:xfrm>
+            <a:off x="10305288" y="7256678"/>
             <a:ext cx="192024" cy="192024"/>
           </a:xfrm>
           <a:prstGeom prst="ellipse">
@@ -15156,13 +15242,13 @@
       </p:sp>
       <p:sp>
         <p:nvSpPr>
-          <p:cNvPr id="120" name="Shape 118"/>
-          <p:cNvSpPr/>
-          <p:nvPr/>
-        </p:nvSpPr>
-        <p:spPr>
-          <a:xfrm>
-            <a:off x="10351008" y="6839712"/>
+          <p:cNvPr id="122" name="Shape 120"/>
+          <p:cNvSpPr/>
+          <p:nvPr/>
+        </p:nvSpPr>
+        <p:spPr>
+          <a:xfrm>
+            <a:off x="10351008" y="7302398"/>
             <a:ext cx="100584" cy="100584"/>
           </a:xfrm>
           <a:prstGeom prst="ellipse">
@@ -15181,13 +15267,13 @@
       </p:sp>
       <p:sp>
         <p:nvSpPr>
-          <p:cNvPr id="121" name="Text 119"/>
-          <p:cNvSpPr/>
-          <p:nvPr/>
-        </p:nvSpPr>
-        <p:spPr>
-          <a:xfrm>
-            <a:off x="10616184" y="6780276"/>
+          <p:cNvPr id="123" name="Text 121"/>
+          <p:cNvSpPr/>
+          <p:nvPr/>
+        </p:nvSpPr>
+        <p:spPr>
+          <a:xfrm>
+            <a:off x="10616184" y="7242962"/>
             <a:ext cx="4050792" cy="237744"/>
           </a:xfrm>
           <a:prstGeom prst="rect">
@@ -15220,13 +15306,13 @@
       </p:sp>
       <p:sp>
         <p:nvSpPr>
-          <p:cNvPr id="122" name="Shape 120"/>
-          <p:cNvSpPr/>
-          <p:nvPr/>
-        </p:nvSpPr>
-        <p:spPr>
-          <a:xfrm>
-            <a:off x="10351008" y="7118604"/>
+          <p:cNvPr id="124" name="Shape 122"/>
+          <p:cNvSpPr/>
+          <p:nvPr/>
+        </p:nvSpPr>
+        <p:spPr>
+          <a:xfrm>
+            <a:off x="10351008" y="7581290"/>
             <a:ext cx="91440" cy="91440"/>
           </a:xfrm>
           <a:prstGeom prst="ellipse">
@@ -15245,13 +15331,13 @@
       </p:sp>
       <p:sp>
         <p:nvSpPr>
-          <p:cNvPr id="123" name="Text 121"/>
-          <p:cNvSpPr/>
-          <p:nvPr/>
-        </p:nvSpPr>
-        <p:spPr>
-          <a:xfrm>
-            <a:off x="10616184" y="7054596"/>
+          <p:cNvPr id="125" name="Text 123"/>
+          <p:cNvSpPr/>
+          <p:nvPr/>
+        </p:nvSpPr>
+        <p:spPr>
+          <a:xfrm>
+            <a:off x="10616184" y="7517282"/>
             <a:ext cx="4050792" cy="237744"/>
           </a:xfrm>
           <a:prstGeom prst="rect">
@@ -15284,13 +15370,13 @@
       </p:sp>
       <p:sp>
         <p:nvSpPr>
-          <p:cNvPr id="124" name="Shape 122"/>
-          <p:cNvSpPr/>
-          <p:nvPr/>
-        </p:nvSpPr>
-        <p:spPr>
-          <a:xfrm>
-            <a:off x="10268712" y="7438644"/>
+          <p:cNvPr id="126" name="Shape 124"/>
+          <p:cNvSpPr/>
+          <p:nvPr/>
+        </p:nvSpPr>
+        <p:spPr>
+          <a:xfrm>
+            <a:off x="10268712" y="7901330"/>
             <a:ext cx="274320" cy="914"/>
           </a:xfrm>
           <a:prstGeom prst="line">
@@ -15307,13 +15393,13 @@
       </p:sp>
       <p:sp>
         <p:nvSpPr>
-          <p:cNvPr id="125" name="Text 123"/>
-          <p:cNvSpPr/>
-          <p:nvPr/>
-        </p:nvSpPr>
-        <p:spPr>
-          <a:xfrm>
-            <a:off x="10616184" y="7328916"/>
+          <p:cNvPr id="127" name="Text 125"/>
+          <p:cNvSpPr/>
+          <p:nvPr/>
+        </p:nvSpPr>
+        <p:spPr>
+          <a:xfrm>
+            <a:off x="10616184" y="7791602"/>
             <a:ext cx="4050792" cy="237744"/>
           </a:xfrm>
           <a:prstGeom prst="rect">
@@ -15346,13 +15432,13 @@
       </p:sp>
       <p:sp>
         <p:nvSpPr>
-          <p:cNvPr id="126" name="Shape 124"/>
-          <p:cNvSpPr/>
-          <p:nvPr/>
-        </p:nvSpPr>
-        <p:spPr>
-          <a:xfrm>
-            <a:off x="10268712" y="7712964"/>
+          <p:cNvPr id="128" name="Shape 126"/>
+          <p:cNvSpPr/>
+          <p:nvPr/>
+        </p:nvSpPr>
+        <p:spPr>
+          <a:xfrm>
+            <a:off x="10268712" y="8175650"/>
             <a:ext cx="274320" cy="914"/>
           </a:xfrm>
           <a:prstGeom prst="line">
@@ -15369,13 +15455,13 @@
       </p:sp>
       <p:sp>
         <p:nvSpPr>
-          <p:cNvPr id="127" name="Text 125"/>
-          <p:cNvSpPr/>
-          <p:nvPr/>
-        </p:nvSpPr>
-        <p:spPr>
-          <a:xfrm>
-            <a:off x="10616184" y="7603236"/>
+          <p:cNvPr id="129" name="Text 127"/>
+          <p:cNvSpPr/>
+          <p:nvPr/>
+        </p:nvSpPr>
+        <p:spPr>
+          <a:xfrm>
+            <a:off x="10616184" y="8065922"/>
             <a:ext cx="4050792" cy="237744"/>
           </a:xfrm>
           <a:prstGeom prst="rect">
@@ -15408,13 +15494,13 @@
       </p:sp>
       <p:sp>
         <p:nvSpPr>
-          <p:cNvPr id="128" name="Shape 126"/>
-          <p:cNvSpPr/>
-          <p:nvPr/>
-        </p:nvSpPr>
-        <p:spPr>
-          <a:xfrm>
-            <a:off x="10268712" y="7987284"/>
+          <p:cNvPr id="130" name="Shape 128"/>
+          <p:cNvSpPr/>
+          <p:nvPr/>
+        </p:nvSpPr>
+        <p:spPr>
+          <a:xfrm>
+            <a:off x="10268712" y="8449970"/>
             <a:ext cx="274320" cy="914"/>
           </a:xfrm>
           <a:prstGeom prst="line">
@@ -15431,13 +15517,13 @@
       </p:sp>
       <p:sp>
         <p:nvSpPr>
-          <p:cNvPr id="129" name="Text 127"/>
-          <p:cNvSpPr/>
-          <p:nvPr/>
-        </p:nvSpPr>
-        <p:spPr>
-          <a:xfrm>
-            <a:off x="10616184" y="7877556"/>
+          <p:cNvPr id="131" name="Text 129"/>
+          <p:cNvSpPr/>
+          <p:nvPr/>
+        </p:nvSpPr>
+        <p:spPr>
+          <a:xfrm>
+            <a:off x="10616184" y="8340242"/>
             <a:ext cx="4050792" cy="237744"/>
           </a:xfrm>
           <a:prstGeom prst="rect">
@@ -15470,13 +15556,13 @@
       </p:sp>
       <p:sp>
         <p:nvSpPr>
-          <p:cNvPr id="130" name="Shape 128"/>
-          <p:cNvSpPr/>
-          <p:nvPr/>
-        </p:nvSpPr>
-        <p:spPr>
-          <a:xfrm>
-            <a:off x="10268712" y="8261604"/>
+          <p:cNvPr id="132" name="Shape 130"/>
+          <p:cNvSpPr/>
+          <p:nvPr/>
+        </p:nvSpPr>
+        <p:spPr>
+          <a:xfrm>
+            <a:off x="10268712" y="8724290"/>
             <a:ext cx="274320" cy="914"/>
           </a:xfrm>
           <a:prstGeom prst="line">
@@ -15493,13 +15579,13 @@
       </p:sp>
       <p:sp>
         <p:nvSpPr>
-          <p:cNvPr id="131" name="Text 129"/>
-          <p:cNvSpPr/>
-          <p:nvPr/>
-        </p:nvSpPr>
-        <p:spPr>
-          <a:xfrm>
-            <a:off x="10616184" y="8151876"/>
+          <p:cNvPr id="133" name="Text 131"/>
+          <p:cNvSpPr/>
+          <p:nvPr/>
+        </p:nvSpPr>
+        <p:spPr>
+          <a:xfrm>
+            <a:off x="10616184" y="8614562"/>
             <a:ext cx="4050792" cy="237744"/>
           </a:xfrm>
           <a:prstGeom prst="rect">
@@ -15532,13 +15618,13 @@
       </p:sp>
       <p:sp>
         <p:nvSpPr>
-          <p:cNvPr id="132" name="Shape 130"/>
-          <p:cNvSpPr/>
-          <p:nvPr/>
-        </p:nvSpPr>
-        <p:spPr>
-          <a:xfrm>
-            <a:off x="10268712" y="8535924"/>
+          <p:cNvPr id="134" name="Shape 132"/>
+          <p:cNvSpPr/>
+          <p:nvPr/>
+        </p:nvSpPr>
+        <p:spPr>
+          <a:xfrm>
+            <a:off x="10268712" y="8998610"/>
             <a:ext cx="274320" cy="914"/>
           </a:xfrm>
           <a:prstGeom prst="line">
@@ -15555,13 +15641,13 @@
       </p:sp>
       <p:sp>
         <p:nvSpPr>
-          <p:cNvPr id="133" name="Text 131"/>
-          <p:cNvSpPr/>
-          <p:nvPr/>
-        </p:nvSpPr>
-        <p:spPr>
-          <a:xfrm>
-            <a:off x="10616184" y="8426196"/>
+          <p:cNvPr id="135" name="Text 133"/>
+          <p:cNvSpPr/>
+          <p:nvPr/>
+        </p:nvSpPr>
+        <p:spPr>
+          <a:xfrm>
+            <a:off x="10616184" y="8888882"/>
             <a:ext cx="4050792" cy="237744"/>
           </a:xfrm>
           <a:prstGeom prst="rect">
@@ -15594,13 +15680,13 @@
       </p:sp>
       <p:sp>
         <p:nvSpPr>
-          <p:cNvPr id="134" name="Shape 132"/>
-          <p:cNvSpPr/>
-          <p:nvPr/>
-        </p:nvSpPr>
-        <p:spPr>
-          <a:xfrm>
-            <a:off x="10287000" y="8727948"/>
+          <p:cNvPr id="136" name="Shape 134"/>
+          <p:cNvSpPr/>
+          <p:nvPr/>
+        </p:nvSpPr>
+        <p:spPr>
+          <a:xfrm>
+            <a:off x="10287000" y="9190634"/>
             <a:ext cx="219456" cy="146304"/>
           </a:xfrm>
           <a:prstGeom prst="rect">
@@ -15616,13 +15702,13 @@
       </p:sp>
       <p:sp>
         <p:nvSpPr>
-          <p:cNvPr id="135" name="Text 133"/>
-          <p:cNvSpPr/>
-          <p:nvPr/>
-        </p:nvSpPr>
-        <p:spPr>
-          <a:xfrm>
-            <a:off x="10616184" y="8700516"/>
+          <p:cNvPr id="137" name="Text 135"/>
+          <p:cNvSpPr/>
+          <p:nvPr/>
+        </p:nvSpPr>
+        <p:spPr>
+          <a:xfrm>
+            <a:off x="10616184" y="9163202"/>
             <a:ext cx="4050792" cy="237744"/>
           </a:xfrm>
           <a:prstGeom prst="rect">

</xml_diff>